<commit_message>
Add Local Impact track image to track page, README, and slides
Co-Authored-By: Claude Opus 5.5 <noreply@anthropic.com>
Claude-Session: https://claude.ai/code/session_01WfF3KTuiPU7i9eXV8nJ9tf
</commit_message>
<xml_diff>
--- a/slides/JacHacks_Welcome_Sponsor_Slides.pptx
+++ b/slides/JacHacks_Welcome_Sponsor_Slides.pptx
@@ -8327,8 +8327,8 @@
         </p:nvSpPr>
         <p:spPr>
           <a:xfrm>
-            <a:off x="370900" y="1828800"/>
-            <a:ext cx="8229600" cy="3200400"/>
+            <a:off x="370900" y="1691640"/>
+            <a:ext cx="4023360" cy="3200400"/>
           </a:xfrm>
           <a:prstGeom prst="rect">
             <a:avLst/>
@@ -8357,7 +8357,7 @@
               <a:buNone/>
             </a:pPr>
             <a:r>
-              <a:rPr lang="en" sz="6000" b="1">
+              <a:rPr lang="en" sz="3600" b="1">
                 <a:solidFill>
                   <a:srgbClr val="FFFFFF"/>
                 </a:solidFill>
@@ -8366,7 +8366,17 @@
                 <a:cs typeface="Google Sans"/>
                 <a:sym typeface="Google Sans"/>
               </a:rPr>
-              <a:t>Local Impact Track</a:t>
+              <a:t>Local Impact</a:t>
+            </a:r>
+            <a:br/>
+            <a:r>
+              <a:rPr sz="3600" b="1">
+                <a:solidFill>
+                  <a:srgbClr val="FFFFFF"/>
+                </a:solidFill>
+                <a:latin typeface="Google Sans"/>
+              </a:rPr>
+              <a:t>Track</a:t>
             </a:r>
             <a:endParaRPr sz="7500">
               <a:solidFill>
@@ -8388,7 +8398,7 @@
               </a:spcBef>
             </a:pPr>
             <a:r>
-              <a:rPr sz="3000" b="0">
+              <a:rPr sz="1700" b="0">
                 <a:solidFill>
                   <a:srgbClr val="CAE6FF"/>
                 </a:solidFill>
@@ -8403,17 +8413,27 @@
                 <a:spcPct val="105000"/>
               </a:lnSpc>
               <a:spcBef>
-                <a:spcPts val="1000"/>
+                <a:spcPts val="1200"/>
               </a:spcBef>
             </a:pPr>
             <a:r>
-              <a:rPr sz="3000" b="1">
+              <a:rPr sz="2000" b="1">
                 <a:solidFill>
                   <a:srgbClr val="FFFFFF"/>
                 </a:solidFill>
                 <a:latin typeface="Google Sans"/>
               </a:rPr>
-              <a:t>Sponsor workshop: 3:00 PM today</a:t>
+              <a:t>Sponsor workshop:</a:t>
+            </a:r>
+            <a:br/>
+            <a:r>
+              <a:rPr sz="2000" b="1">
+                <a:solidFill>
+                  <a:srgbClr val="FFFFFF"/>
+                </a:solidFill>
+                <a:latin typeface="Google Sans"/>
+              </a:rPr>
+              <a:t>3:00 PM today</a:t>
             </a:r>
           </a:p>
         </p:txBody>
@@ -8542,6 +8562,30 @@
           <a:ln>
             <a:noFill/>
           </a:ln>
+        </p:spPr>
+      </p:pic>
+      <p:pic>
+        <p:nvPicPr>
+          <p:cNvPr id="97" name="Picture 96" descr="local-impact-track.jpg"/>
+          <p:cNvPicPr>
+            <a:picLocks noChangeAspect="1"/>
+          </p:cNvPicPr>
+          <p:nvPr/>
+        </p:nvPicPr>
+        <p:blipFill>
+          <a:blip r:embed="rId5"/>
+          <a:stretch>
+            <a:fillRect/>
+          </a:stretch>
+        </p:blipFill>
+        <p:spPr>
+          <a:xfrm>
+            <a:off x="4434840" y="320040"/>
+            <a:ext cx="4526280" cy="4526280"/>
+          </a:xfrm>
+          <a:prstGeom prst="rect">
+            <a:avLst/>
+          </a:prstGeom>
         </p:spPr>
       </p:pic>
     </p:spTree>

</xml_diff>

<commit_message>
Restore slides without the Local Impact image
Co-Authored-By: Claude Opus 5.5 <noreply@anthropic.com>
Claude-Session: https://claude.ai/code/session_01WfF3KTuiPU7i9eXV8nJ9tf
</commit_message>
<xml_diff>
--- a/slides/JacHacks_Welcome_Sponsor_Slides.pptx
+++ b/slides/JacHacks_Welcome_Sponsor_Slides.pptx
@@ -8327,8 +8327,8 @@
         </p:nvSpPr>
         <p:spPr>
           <a:xfrm>
-            <a:off x="370900" y="1691640"/>
-            <a:ext cx="4023360" cy="3200400"/>
+            <a:off x="370900" y="1828800"/>
+            <a:ext cx="8229600" cy="3200400"/>
           </a:xfrm>
           <a:prstGeom prst="rect">
             <a:avLst/>
@@ -8357,7 +8357,7 @@
               <a:buNone/>
             </a:pPr>
             <a:r>
-              <a:rPr lang="en" sz="3600" b="1">
+              <a:rPr lang="en" sz="6000" b="1">
                 <a:solidFill>
                   <a:srgbClr val="FFFFFF"/>
                 </a:solidFill>
@@ -8366,17 +8366,7 @@
                 <a:cs typeface="Google Sans"/>
                 <a:sym typeface="Google Sans"/>
               </a:rPr>
-              <a:t>Local Impact</a:t>
-            </a:r>
-            <a:br/>
-            <a:r>
-              <a:rPr sz="3600" b="1">
-                <a:solidFill>
-                  <a:srgbClr val="FFFFFF"/>
-                </a:solidFill>
-                <a:latin typeface="Google Sans"/>
-              </a:rPr>
-              <a:t>Track</a:t>
+              <a:t>Local Impact Track</a:t>
             </a:r>
             <a:endParaRPr sz="7500">
               <a:solidFill>
@@ -8398,7 +8388,7 @@
               </a:spcBef>
             </a:pPr>
             <a:r>
-              <a:rPr sz="1700" b="0">
+              <a:rPr sz="3000" b="0">
                 <a:solidFill>
                   <a:srgbClr val="CAE6FF"/>
                 </a:solidFill>
@@ -8413,27 +8403,17 @@
                 <a:spcPct val="105000"/>
               </a:lnSpc>
               <a:spcBef>
-                <a:spcPts val="1200"/>
+                <a:spcPts val="1000"/>
               </a:spcBef>
             </a:pPr>
             <a:r>
-              <a:rPr sz="2000" b="1">
+              <a:rPr sz="3000" b="1">
                 <a:solidFill>
                   <a:srgbClr val="FFFFFF"/>
                 </a:solidFill>
                 <a:latin typeface="Google Sans"/>
               </a:rPr>
-              <a:t>Sponsor workshop:</a:t>
-            </a:r>
-            <a:br/>
-            <a:r>
-              <a:rPr sz="2000" b="1">
-                <a:solidFill>
-                  <a:srgbClr val="FFFFFF"/>
-                </a:solidFill>
-                <a:latin typeface="Google Sans"/>
-              </a:rPr>
-              <a:t>3:00 PM today</a:t>
+              <a:t>Sponsor workshop: 3:00 PM today</a:t>
             </a:r>
           </a:p>
         </p:txBody>
@@ -8562,30 +8542,6 @@
           <a:ln>
             <a:noFill/>
           </a:ln>
-        </p:spPr>
-      </p:pic>
-      <p:pic>
-        <p:nvPicPr>
-          <p:cNvPr id="97" name="Picture 96" descr="local-impact-track.jpg"/>
-          <p:cNvPicPr>
-            <a:picLocks noChangeAspect="1"/>
-          </p:cNvPicPr>
-          <p:nvPr/>
-        </p:nvPicPr>
-        <p:blipFill>
-          <a:blip r:embed="rId5"/>
-          <a:stretch>
-            <a:fillRect/>
-          </a:stretch>
-        </p:blipFill>
-        <p:spPr>
-          <a:xfrm>
-            <a:off x="4434840" y="320040"/>
-            <a:ext cx="4526280" cy="4526280"/>
-          </a:xfrm>
-          <a:prstGeom prst="rect">
-            <a:avLst/>
-          </a:prstGeom>
         </p:spPr>
       </p:pic>
     </p:spTree>

</xml_diff>